<commit_message>
Fill in author and guide details in the Review III manuscript
Co-Authored-By: Claude Opus 5.5 <noreply@anthropic.com>
</commit_message>
<xml_diff>
--- a/docs/review3/BranchLab_Review3_Presentation.pptx
+++ b/docs/review3/BranchLab_Review3_Presentation.pptx
@@ -119,14 +119,14 @@
   <p:extLst>
     <p:ext uri="{521415D9-36F7-43E2-AB2F-B90AF26B5E84}">
       <p14:sectionLst xmlns:p14="http://schemas.microsoft.com/office/powerpoint/2010/main">
-        <p14:section name="Introduction" id="{6ba83b4c-9ef5-c788-0f74-d71aa1611ce8}">
+        <p14:section name="Introduction" id="{85462c43-d290-ec0c-bb2f-89d9a06178c9}">
           <p14:sldIdLst>
             <p14:sldId id="256"/>
             <p14:sldId id="257"/>
             <p14:sldId id="258"/>
           </p14:sldIdLst>
         </p14:section>
-        <p14:section name="Completion and demo" id="{11f0c78b-ee48-bbed-4ee3-ae2a97de066e}">
+        <p14:section name="Completion and demo" id="{03f3a61b-f2cf-eb52-74be-9c18da8650b8}">
           <p14:sldIdLst>
             <p14:sldId id="259"/>
             <p14:sldId id="260"/>
@@ -136,13 +136,13 @@
             <p14:sldId id="264"/>
           </p14:sldIdLst>
         </p14:section>
-        <p14:section name="Individual contribution" id="{c065227d-f50f-eabd-f48f-de68a169260d}">
+        <p14:section name="Individual contribution" id="{87ce3a47-fd97-82ce-4fb4-ef664caf310c}">
           <p14:sldIdLst>
             <p14:sldId id="265"/>
             <p14:sldId id="266"/>
           </p14:sldIdLst>
         </p14:section>
-        <p14:section name="Project outcome" id="{1180d2f3-3cab-bbad-c803-4ea5b542b0ea}">
+        <p14:section name="Project outcome" id="{7273de8f-7b48-c752-fcbd-7a06b3146879}">
           <p14:sldIdLst>
             <p14:sldId id="267"/>
             <p14:sldId id="268"/>
@@ -640,7 +640,7 @@
           <a:p>
             <a:r>
               <a:rPr lang="en-US" dirty="0"/>
-              <a:t>I am the only team member, so every part is my work: the analysis, generation, execution and coverage engine, the web interface, the evaluation, the deployment and the manuscript. The Git history records 49 commits from 6 to 28 October. The phases: first the Python AST parser and boundary generator; then Tree-sitter support for Java and C and the multi-language runner; then probes, the read map, statement coverage, the interface and the evaluation; and finally the benchmarks, deployment and manuscript. 252 automated tests check the tool, always against real outputs rather than reported coverage.</a:t>
+              <a:t>I am the only team member, so every part is my work: the analysis, generation, execution and coverage engine, the web interface, the evaluation, the deployment and the manuscript. The Git history records 51 commits from 6 to 28 October. The phases: first the Python AST parser and boundary generator; then Tree-sitter support for Java and C and the multi-language runner; then probes, the read map, statement coverage, the interface and the evaluation; and finally the benchmarks, deployment and manuscript. 252 automated tests check the tool, always against real outputs rather than reported coverage.</a:t>
             </a:r>
             <a:endParaRPr lang="en-US" dirty="0"/>
           </a:p>
@@ -3476,7 +3476,7 @@
                   <a:schemeClr val="tx1"/>
                 </a:solidFill>
               </a:rPr>
-              <a:t>49</a:t>
+              <a:t>51</a:t>
             </a:r>
             <a:endParaRPr lang="en-US" sz="4000" dirty="0"/>
           </a:p>

</xml_diff>

<commit_message>
Add the guide's e-mail to the Review III manuscript
Co-Authored-By: Claude Opus 5.5 <noreply@anthropic.com>
</commit_message>
<xml_diff>
--- a/docs/review3/BranchLab_Review3_Presentation.pptx
+++ b/docs/review3/BranchLab_Review3_Presentation.pptx
@@ -119,14 +119,14 @@
   <p:extLst>
     <p:ext uri="{521415D9-36F7-43E2-AB2F-B90AF26B5E84}">
       <p14:sectionLst xmlns:p14="http://schemas.microsoft.com/office/powerpoint/2010/main">
-        <p14:section name="Introduction" id="{85462c43-d290-ec0c-bb2f-89d9a06178c9}">
+        <p14:section name="Introduction" id="{2ab964d5-46cb-abb7-4855-2cac6d2b2633}">
           <p14:sldIdLst>
             <p14:sldId id="256"/>
             <p14:sldId id="257"/>
             <p14:sldId id="258"/>
           </p14:sldIdLst>
         </p14:section>
-        <p14:section name="Completion and demo" id="{03f3a61b-f2cf-eb52-74be-9c18da8650b8}">
+        <p14:section name="Completion and demo" id="{87c74276-504e-d389-6aff-16d21d91d139}">
           <p14:sldIdLst>
             <p14:sldId id="259"/>
             <p14:sldId id="260"/>
@@ -136,13 +136,13 @@
             <p14:sldId id="264"/>
           </p14:sldIdLst>
         </p14:section>
-        <p14:section name="Individual contribution" id="{87ce3a47-fd97-82ce-4fb4-ef664caf310c}">
+        <p14:section name="Individual contribution" id="{4c87bed7-67a2-27ec-d165-ffe970725a07}">
           <p14:sldIdLst>
             <p14:sldId id="265"/>
             <p14:sldId id="266"/>
           </p14:sldIdLst>
         </p14:section>
-        <p14:section name="Project outcome" id="{7273de8f-7b48-c752-fcbd-7a06b3146879}">
+        <p14:section name="Project outcome" id="{fd44049b-a57e-7557-7331-4770b0ffcce4}">
           <p14:sldIdLst>
             <p14:sldId id="267"/>
             <p14:sldId id="268"/>
@@ -640,7 +640,7 @@
           <a:p>
             <a:r>
               <a:rPr lang="en-US" dirty="0"/>
-              <a:t>I am the only team member, so every part is my work: the analysis, generation, execution and coverage engine, the web interface, the evaluation, the deployment and the manuscript. The Git history records 51 commits from 6 to 28 October. The phases: first the Python AST parser and boundary generator; then Tree-sitter support for Java and C and the multi-language runner; then probes, the read map, statement coverage, the interface and the evaluation; and finally the benchmarks, deployment and manuscript. 252 automated tests check the tool, always against real outputs rather than reported coverage.</a:t>
+              <a:t>I am the only team member, so every part is my work: the analysis, generation, execution and coverage engine, the web interface, the evaluation, the deployment and the manuscript. The Git history records 52 commits from 6 to 28 October. The phases: first the Python AST parser and boundary generator; then Tree-sitter support for Java and C and the multi-language runner; then probes, the read map, statement coverage, the interface and the evaluation; and finally the benchmarks, deployment and manuscript. 252 automated tests check the tool, always against real outputs rather than reported coverage.</a:t>
             </a:r>
             <a:endParaRPr lang="en-US" dirty="0"/>
           </a:p>
@@ -3476,7 +3476,7 @@
                   <a:schemeClr val="tx1"/>
                 </a:solidFill>
               </a:rPr>
-              <a:t>51</a:t>
+              <a:t>52</a:t>
             </a:r>
             <a:endParaRPr lang="en-US" sz="4000" dirty="0"/>
           </a:p>

</xml_diff>